<commit_message>
feat: add editable timelines and fixed page management
</commit_message>
<xml_diff>
--- a/output/丽水学院_WebSlide制作与演示指南.pptx
+++ b/output/丽水学院_WebSlide制作与演示指南.pptx
@@ -8552,11 +8552,11 @@
             <a:avLst/>
           </a:prstGeom>
           <a:solidFill>
-            <a:srgbClr val="FFFFFF"/>
+            <a:srgbClr val="EDF6F5"/>
           </a:solidFill>
           <a:ln w="12700">
             <a:solidFill>
-              <a:srgbClr val="FFFFFF">
+              <a:srgbClr val="EDF6F5">
                 <a:alpha val="0"/>
               </a:srgbClr>
             </a:solidFill>
@@ -8564,106 +8564,226 @@
           </a:ln>
         </p:spPr>
       </p:sp>
-      <p:pic>
-        <p:nvPicPr>
-          <p:cNvPr id="20" name="Image 1" descr="preencoded.png">    </p:cNvPr>
-          <p:cNvPicPr>
-            <a:picLocks noChangeAspect="1"/>
-          </p:cNvPicPr>
-          <p:nvPr/>
-        </p:nvPicPr>
-        <p:blipFill>
-          <a:blip r:embed="rId2"/>
-          <a:stretch>
-            <a:fillRect/>
-          </a:stretch>
-        </p:blipFill>
-        <p:spPr>
-          <a:xfrm>
-            <a:off x="6416040" y="2072640"/>
-            <a:ext cx="685800" cy="365760"/>
-          </a:xfrm>
-          <a:prstGeom prst="rect">
-            <a:avLst/>
-          </a:prstGeom>
-        </p:spPr>
-      </p:pic>
-      <p:pic>
-        <p:nvPicPr>
-          <p:cNvPr id="21" name="Image 2" descr="preencoded.png">    </p:cNvPr>
-          <p:cNvPicPr>
-            <a:picLocks noChangeAspect="1"/>
-          </p:cNvPicPr>
-          <p:nvPr/>
-        </p:nvPicPr>
-        <p:blipFill>
-          <a:blip r:embed="rId3"/>
-          <a:stretch>
-            <a:fillRect/>
-          </a:stretch>
-        </p:blipFill>
-        <p:spPr>
-          <a:xfrm>
-            <a:off x="6294120" y="2072640"/>
-            <a:ext cx="685800" cy="365760"/>
-          </a:xfrm>
-          <a:prstGeom prst="rect">
-            <a:avLst/>
-          </a:prstGeom>
-        </p:spPr>
-      </p:pic>
-      <p:sp>
-        <p:nvSpPr>
-          <p:cNvPr id="22" name="Text 16"/>
-          <p:cNvSpPr/>
-          <p:nvPr/>
-        </p:nvSpPr>
-        <p:spPr>
-          <a:xfrm>
-            <a:off x="6385560" y="2090499"/>
-            <a:ext cx="254079" cy="330041"/>
-          </a:xfrm>
-          <a:prstGeom prst="rect">
-            <a:avLst/>
-          </a:prstGeom>
-          <a:noFill/>
-          <a:ln/>
-        </p:spPr>
-        <p:txBody>
-          <a:bodyPr wrap="none" lIns="0" tIns="0" rIns="0" bIns="0" rtlCol="0" anchor="ctr"/>
+      <p:sp>
+        <p:nvSpPr>
+          <p:cNvPr id="20" name="Text 16"/>
+          <p:cNvSpPr/>
+          <p:nvPr/>
+        </p:nvSpPr>
+        <p:spPr>
+          <a:xfrm>
+            <a:off x="6294120" y="2026920"/>
+            <a:ext cx="5303520" cy="297180"/>
+          </a:xfrm>
+          <a:prstGeom prst="rect">
+            <a:avLst/>
+          </a:prstGeom>
+          <a:noFill/>
+          <a:ln/>
+        </p:spPr>
+        <p:txBody>
+          <a:bodyPr wrap="square" lIns="0" tIns="0" rIns="0" bIns="0" rtlCol="0" anchor="ctr"/>
           <a:lstStyle/>
           <a:p>
             <a:pPr algn="l" indent="0" marL="0">
               <a:lnSpc>
-                <a:spcPts val="2600"/>
-              </a:lnSpc>
-              <a:buNone/>
-            </a:pPr>
-            <a:r>
-              <a:rPr lang="en-US" sz="2000" b="1" dirty="0">
+                <a:spcPts val="2340"/>
+              </a:lnSpc>
+              <a:buNone/>
+            </a:pPr>
+            <a:r>
+              <a:rPr lang="en-US" sz="1800" b="1" dirty="0">
                 <a:solidFill>
                   <a:srgbClr val="FFFFFF"/>
                 </a:solidFill>
-                <a:latin typeface="Times New Roman" pitchFamily="34" charset="0"/>
-                <a:ea typeface="Times New Roman" pitchFamily="34" charset="-122"/>
-                <a:cs typeface="Times New Roman" pitchFamily="34" charset="-120"/>
-              </a:rPr>
-              <a:t>01</a:t>
-            </a:r>
-            <a:endParaRPr lang="en-US" sz="2000" dirty="0"/>
-          </a:p>
-        </p:txBody>
-      </p:sp>
-      <p:sp>
-        <p:nvSpPr>
-          <p:cNvPr id="23" name="Text 17"/>
-          <p:cNvSpPr/>
-          <p:nvPr/>
-        </p:nvSpPr>
-        <p:spPr>
-          <a:xfrm>
-            <a:off x="7223760" y="2106930"/>
-            <a:ext cx="4373880" cy="297180"/>
+                <a:latin typeface="Microsoft YaHei" pitchFamily="34" charset="0"/>
+                <a:ea typeface="Microsoft YaHei" pitchFamily="34" charset="-122"/>
+                <a:cs typeface="Microsoft YaHei" pitchFamily="34" charset="-120"/>
+              </a:rPr>
+              <a:t>操作路径</a:t>
+            </a:r>
+            <a:endParaRPr lang="en-US" sz="1800" dirty="0"/>
+          </a:p>
+        </p:txBody>
+      </p:sp>
+      <p:sp>
+        <p:nvSpPr>
+          <p:cNvPr id="21" name="Text 17"/>
+          <p:cNvSpPr/>
+          <p:nvPr/>
+        </p:nvSpPr>
+        <p:spPr>
+          <a:xfrm>
+            <a:off x="6294120" y="2522220"/>
+            <a:ext cx="5303520" cy="314920"/>
+          </a:xfrm>
+          <a:prstGeom prst="rect">
+            <a:avLst/>
+          </a:prstGeom>
+          <a:noFill/>
+          <a:ln/>
+        </p:spPr>
+        <p:txBody>
+          <a:bodyPr wrap="square" lIns="0" tIns="0" rIns="0" bIns="0" rtlCol="0" anchor="ctr"/>
+          <a:lstStyle/>
+          <a:p>
+            <a:pPr algn="just" indent="0" marL="0">
+              <a:lnSpc>
+                <a:spcPts val="2480"/>
+              </a:lnSpc>
+              <a:buNone/>
+            </a:pPr>
+            <a:r>
+              <a:rPr lang="en-US" sz="1600" dirty="0">
+                <a:solidFill>
+                  <a:srgbClr val="18383F"/>
+                </a:solidFill>
+                <a:latin typeface="Microsoft YaHei" pitchFamily="34" charset="0"/>
+                <a:ea typeface="Microsoft YaHei" pitchFamily="34" charset="-122"/>
+                <a:cs typeface="Microsoft YaHei" pitchFamily="34" charset="-120"/>
+              </a:rPr>
+              <a:t>双击占位区域打开弹窗；选择本地图片或视频。</a:t>
+            </a:r>
+            <a:endParaRPr lang="en-US" sz="1600" dirty="0"/>
+          </a:p>
+        </p:txBody>
+      </p:sp>
+      <p:sp>
+        <p:nvSpPr>
+          <p:cNvPr id="22" name="Text 18"/>
+          <p:cNvSpPr/>
+          <p:nvPr/>
+        </p:nvSpPr>
+        <p:spPr>
+          <a:xfrm>
+            <a:off x="6294120" y="2913340"/>
+            <a:ext cx="5303520" cy="629841"/>
+          </a:xfrm>
+          <a:prstGeom prst="rect">
+            <a:avLst/>
+          </a:prstGeom>
+          <a:noFill/>
+          <a:ln/>
+        </p:spPr>
+        <p:txBody>
+          <a:bodyPr wrap="square" lIns="0" tIns="0" rIns="0" bIns="0" rtlCol="0" anchor="ctr"/>
+          <a:lstStyle/>
+          <a:p>
+            <a:pPr algn="just" indent="0" marL="0">
+              <a:lnSpc>
+                <a:spcPts val="2480"/>
+              </a:lnSpc>
+              <a:buNone/>
+            </a:pPr>
+            <a:r>
+              <a:rPr lang="en-US" sz="1600" dirty="0">
+                <a:solidFill>
+                  <a:srgbClr val="18383F"/>
+                </a:solidFill>
+                <a:latin typeface="Microsoft YaHei" pitchFamily="34" charset="0"/>
+                <a:ea typeface="Microsoft YaHei" pitchFamily="34" charset="-122"/>
+                <a:cs typeface="Microsoft YaHei" pitchFamily="34" charset="-120"/>
+              </a:rPr>
+              <a:t>从预设或自定义宽高比中选择；用水平、垂直取景调整画面位置。</a:t>
+            </a:r>
+            <a:endParaRPr lang="en-US" sz="1600" dirty="0"/>
+          </a:p>
+        </p:txBody>
+      </p:sp>
+      <p:sp>
+        <p:nvSpPr>
+          <p:cNvPr id="23" name="Text 19"/>
+          <p:cNvSpPr/>
+          <p:nvPr/>
+        </p:nvSpPr>
+        <p:spPr>
+          <a:xfrm>
+            <a:off x="6294120" y="3619381"/>
+            <a:ext cx="5303520" cy="314920"/>
+          </a:xfrm>
+          <a:prstGeom prst="rect">
+            <a:avLst/>
+          </a:prstGeom>
+          <a:noFill/>
+          <a:ln/>
+        </p:spPr>
+        <p:txBody>
+          <a:bodyPr wrap="square" lIns="0" tIns="0" rIns="0" bIns="0" rtlCol="0" anchor="ctr"/>
+          <a:lstStyle/>
+          <a:p>
+            <a:pPr algn="just" indent="0" marL="0">
+              <a:lnSpc>
+                <a:spcPts val="2480"/>
+              </a:lnSpc>
+              <a:buNone/>
+            </a:pPr>
+            <a:r>
+              <a:rPr lang="en-US" sz="1600" dirty="0">
+                <a:solidFill>
+                  <a:srgbClr val="18383F"/>
+                </a:solidFill>
+                <a:latin typeface="Microsoft YaHei" pitchFamily="34" charset="0"/>
+                <a:ea typeface="Microsoft YaHei" pitchFamily="34" charset="-122"/>
+                <a:cs typeface="Microsoft YaHei" pitchFamily="34" charset="-120"/>
+              </a:rPr>
+              <a:t>等比放大突出重点；图注可选标题或标题加说明。</a:t>
+            </a:r>
+            <a:endParaRPr lang="en-US" sz="1600" dirty="0"/>
+          </a:p>
+        </p:txBody>
+      </p:sp>
+      <p:sp>
+        <p:nvSpPr>
+          <p:cNvPr id="24" name="Text 20"/>
+          <p:cNvSpPr/>
+          <p:nvPr/>
+        </p:nvSpPr>
+        <p:spPr>
+          <a:xfrm>
+            <a:off x="6294120" y="4010501"/>
+            <a:ext cx="5303520" cy="314920"/>
+          </a:xfrm>
+          <a:prstGeom prst="rect">
+            <a:avLst/>
+          </a:prstGeom>
+          <a:noFill/>
+          <a:ln/>
+        </p:spPr>
+        <p:txBody>
+          <a:bodyPr wrap="square" lIns="0" tIns="0" rIns="0" bIns="0" rtlCol="0" anchor="ctr"/>
+          <a:lstStyle/>
+          <a:p>
+            <a:pPr algn="just" indent="0" marL="0">
+              <a:lnSpc>
+                <a:spcPts val="2480"/>
+              </a:lnSpc>
+              <a:buNone/>
+            </a:pPr>
+            <a:r>
+              <a:rPr lang="en-US" sz="1600" dirty="0">
+                <a:solidFill>
+                  <a:srgbClr val="18383F"/>
+                </a:solidFill>
+                <a:latin typeface="Microsoft YaHei" pitchFamily="34" charset="0"/>
+                <a:ea typeface="Microsoft YaHei" pitchFamily="34" charset="-122"/>
+                <a:cs typeface="Microsoft YaHei" pitchFamily="34" charset="-120"/>
+              </a:rPr>
+              <a:t>确认图注与画面的间隙；无需图注时关闭图标题。</a:t>
+            </a:r>
+            <a:endParaRPr lang="en-US" sz="1600" dirty="0"/>
+          </a:p>
+        </p:txBody>
+      </p:sp>
+      <p:sp>
+        <p:nvSpPr>
+          <p:cNvPr id="25" name="Text 21"/>
+          <p:cNvSpPr/>
+          <p:nvPr/>
+        </p:nvSpPr>
+        <p:spPr>
+          <a:xfrm>
+            <a:off x="6294120" y="4447342"/>
+            <a:ext cx="5303520" cy="314920"/>
           </a:xfrm>
           <a:prstGeom prst="rect">
             <a:avLst/>
@@ -8677,12 +8797,12 @@
           <a:p>
             <a:pPr algn="l" indent="0" marL="0">
               <a:lnSpc>
-                <a:spcPts val="2340"/>
-              </a:lnSpc>
-              <a:buNone/>
-            </a:pPr>
-            <a:r>
-              <a:rPr lang="en-US" sz="1800" b="1" dirty="0">
+                <a:spcPts val="2480"/>
+              </a:lnSpc>
+              <a:buNone/>
+            </a:pPr>
+            <a:r>
+              <a:rPr lang="en-US" sz="1600" b="1" dirty="0">
                 <a:solidFill>
                   <a:srgbClr val="18383F"/>
                 </a:solidFill>
@@ -8690,68 +8810,41 @@
                 <a:ea typeface="Microsoft YaHei" pitchFamily="34" charset="-122"/>
                 <a:cs typeface="Microsoft YaHei" pitchFamily="34" charset="-120"/>
               </a:rPr>
-              <a:t>操作路径</a:t>
-            </a:r>
-            <a:endParaRPr lang="en-US" sz="1800" dirty="0"/>
-          </a:p>
-        </p:txBody>
-      </p:sp>
-      <p:sp>
-        <p:nvSpPr>
-          <p:cNvPr id="24" name="Shape 18"/>
-          <p:cNvSpPr/>
-          <p:nvPr/>
-        </p:nvSpPr>
-        <p:spPr>
-          <a:xfrm>
-            <a:off x="6294120" y="2430780"/>
-            <a:ext cx="5303520" cy="7620"/>
-          </a:xfrm>
-          <a:prstGeom prst="rect">
-            <a:avLst/>
-          </a:prstGeom>
-          <a:solidFill>
-            <a:srgbClr val="0F6674"/>
-          </a:solidFill>
-          <a:ln w="12700">
-            <a:solidFill>
-              <a:srgbClr val="0F6674">
-                <a:alpha val="0"/>
-              </a:srgbClr>
-            </a:solidFill>
-            <a:prstDash val="solid"/>
-          </a:ln>
-        </p:spPr>
-      </p:sp>
-      <p:sp>
-        <p:nvSpPr>
-          <p:cNvPr id="25" name="Text 19"/>
-          <p:cNvSpPr/>
-          <p:nvPr/>
-        </p:nvSpPr>
-        <p:spPr>
-          <a:xfrm>
-            <a:off x="6294120" y="2537460"/>
-            <a:ext cx="5303520" cy="314920"/>
-          </a:xfrm>
-          <a:prstGeom prst="rect">
-            <a:avLst/>
-          </a:prstGeom>
-          <a:noFill/>
-          <a:ln/>
-        </p:spPr>
-        <p:txBody>
-          <a:bodyPr wrap="square" lIns="0" tIns="0" rIns="0" bIns="0" rtlCol="0" anchor="ctr"/>
-          <a:lstStyle/>
-          <a:p>
-            <a:pPr algn="just" indent="0" marL="0">
-              <a:lnSpc>
-                <a:spcPts val="2480"/>
-              </a:lnSpc>
-              <a:buNone/>
-            </a:pPr>
-            <a:r>
-              <a:rPr lang="en-US" sz="1600" dirty="0">
+              <a:t>保持原始比例，避免单向拉伸</a:t>
+            </a:r>
+            <a:endParaRPr lang="en-US" sz="1600" dirty="0"/>
+          </a:p>
+        </p:txBody>
+      </p:sp>
+      <p:sp>
+        <p:nvSpPr>
+          <p:cNvPr id="26" name="Text 22"/>
+          <p:cNvSpPr/>
+          <p:nvPr/>
+        </p:nvSpPr>
+        <p:spPr>
+          <a:xfrm>
+            <a:off x="6294120" y="4884182"/>
+            <a:ext cx="5303520" cy="248841"/>
+          </a:xfrm>
+          <a:prstGeom prst="rect">
+            <a:avLst/>
+          </a:prstGeom>
+          <a:noFill/>
+          <a:ln/>
+        </p:spPr>
+        <p:txBody>
+          <a:bodyPr wrap="square" lIns="0" tIns="0" rIns="0" bIns="0" rtlCol="0" anchor="ctr"/>
+          <a:lstStyle/>
+          <a:p>
+            <a:pPr algn="l" indent="0" marL="0">
+              <a:lnSpc>
+                <a:spcPts val="1960"/>
+              </a:lnSpc>
+              <a:buNone/>
+            </a:pPr>
+            <a:r>
+              <a:rPr lang="en-US" sz="1400" dirty="0">
                 <a:solidFill>
                   <a:srgbClr val="18383F"/>
                 </a:solidFill>
@@ -8759,148 +8852,22 @@
                 <a:ea typeface="Microsoft YaHei" pitchFamily="34" charset="-122"/>
                 <a:cs typeface="Microsoft YaHei" pitchFamily="34" charset="-120"/>
               </a:rPr>
-              <a:t>双击占位区域打开弹窗；选择本地图片或视频。</a:t>
-            </a:r>
-            <a:endParaRPr lang="en-US" sz="1600" dirty="0"/>
-          </a:p>
-        </p:txBody>
-      </p:sp>
-      <p:sp>
-        <p:nvSpPr>
-          <p:cNvPr id="26" name="Text 20"/>
-          <p:cNvSpPr/>
-          <p:nvPr/>
-        </p:nvSpPr>
-        <p:spPr>
-          <a:xfrm>
-            <a:off x="6294120" y="2928580"/>
-            <a:ext cx="5303520" cy="629841"/>
-          </a:xfrm>
-          <a:prstGeom prst="rect">
-            <a:avLst/>
-          </a:prstGeom>
-          <a:noFill/>
-          <a:ln/>
-        </p:spPr>
-        <p:txBody>
-          <a:bodyPr wrap="square" lIns="0" tIns="0" rIns="0" bIns="0" rtlCol="0" anchor="ctr"/>
-          <a:lstStyle/>
-          <a:p>
-            <a:pPr algn="just" indent="0" marL="0">
-              <a:lnSpc>
-                <a:spcPts val="2480"/>
-              </a:lnSpc>
-              <a:buNone/>
-            </a:pPr>
-            <a:r>
-              <a:rPr lang="en-US" sz="1600" dirty="0">
-                <a:solidFill>
-                  <a:srgbClr val="18383F"/>
-                </a:solidFill>
-                <a:latin typeface="Microsoft YaHei" pitchFamily="34" charset="0"/>
-                <a:ea typeface="Microsoft YaHei" pitchFamily="34" charset="-122"/>
-                <a:cs typeface="Microsoft YaHei" pitchFamily="34" charset="-120"/>
-              </a:rPr>
-              <a:t>从预设或自定义宽高比中选择；用水平、垂直取景调整画面位置。</a:t>
-            </a:r>
-            <a:endParaRPr lang="en-US" sz="1600" dirty="0"/>
-          </a:p>
-        </p:txBody>
-      </p:sp>
-      <p:sp>
-        <p:nvSpPr>
-          <p:cNvPr id="27" name="Text 21"/>
-          <p:cNvSpPr/>
-          <p:nvPr/>
-        </p:nvSpPr>
-        <p:spPr>
-          <a:xfrm>
-            <a:off x="6294120" y="3634621"/>
-            <a:ext cx="5303520" cy="314920"/>
-          </a:xfrm>
-          <a:prstGeom prst="rect">
-            <a:avLst/>
-          </a:prstGeom>
-          <a:noFill/>
-          <a:ln/>
-        </p:spPr>
-        <p:txBody>
-          <a:bodyPr wrap="square" lIns="0" tIns="0" rIns="0" bIns="0" rtlCol="0" anchor="ctr"/>
-          <a:lstStyle/>
-          <a:p>
-            <a:pPr algn="just" indent="0" marL="0">
-              <a:lnSpc>
-                <a:spcPts val="2480"/>
-              </a:lnSpc>
-              <a:buNone/>
-            </a:pPr>
-            <a:r>
-              <a:rPr lang="en-US" sz="1600" dirty="0">
-                <a:solidFill>
-                  <a:srgbClr val="18383F"/>
-                </a:solidFill>
-                <a:latin typeface="Microsoft YaHei" pitchFamily="34" charset="0"/>
-                <a:ea typeface="Microsoft YaHei" pitchFamily="34" charset="-122"/>
-                <a:cs typeface="Microsoft YaHei" pitchFamily="34" charset="-120"/>
-              </a:rPr>
-              <a:t>等比放大突出重点；图注可选标题或标题加说明。</a:t>
-            </a:r>
-            <a:endParaRPr lang="en-US" sz="1600" dirty="0"/>
-          </a:p>
-        </p:txBody>
-      </p:sp>
-      <p:sp>
-        <p:nvSpPr>
-          <p:cNvPr id="28" name="Text 22"/>
-          <p:cNvSpPr/>
-          <p:nvPr/>
-        </p:nvSpPr>
-        <p:spPr>
-          <a:xfrm>
-            <a:off x="6294120" y="4025741"/>
-            <a:ext cx="5303520" cy="314920"/>
-          </a:xfrm>
-          <a:prstGeom prst="rect">
-            <a:avLst/>
-          </a:prstGeom>
-          <a:noFill/>
-          <a:ln/>
-        </p:spPr>
-        <p:txBody>
-          <a:bodyPr wrap="square" lIns="0" tIns="0" rIns="0" bIns="0" rtlCol="0" anchor="ctr"/>
-          <a:lstStyle/>
-          <a:p>
-            <a:pPr algn="just" indent="0" marL="0">
-              <a:lnSpc>
-                <a:spcPts val="2480"/>
-              </a:lnSpc>
-              <a:buNone/>
-            </a:pPr>
-            <a:r>
-              <a:rPr lang="en-US" sz="1600" dirty="0">
-                <a:solidFill>
-                  <a:srgbClr val="18383F"/>
-                </a:solidFill>
-                <a:latin typeface="Microsoft YaHei" pitchFamily="34" charset="0"/>
-                <a:ea typeface="Microsoft YaHei" pitchFamily="34" charset="-122"/>
-                <a:cs typeface="Microsoft YaHei" pitchFamily="34" charset="-120"/>
-              </a:rPr>
-              <a:t>确认图注与画面的间隙；无需图注时关闭图标题。</a:t>
-            </a:r>
-            <a:endParaRPr lang="en-US" sz="1600" dirty="0"/>
-          </a:p>
-        </p:txBody>
-      </p:sp>
-      <p:sp>
-        <p:nvSpPr>
-          <p:cNvPr id="29" name="Text 23"/>
-          <p:cNvSpPr/>
-          <p:nvPr/>
-        </p:nvSpPr>
-        <p:spPr>
-          <a:xfrm>
-            <a:off x="6294120" y="4439722"/>
-            <a:ext cx="5303520" cy="314920"/>
+              <a:t>PDF 显示视频静态帧；PPTX 可内嵌视频。</a:t>
+            </a:r>
+            <a:endParaRPr lang="en-US" sz="1400" dirty="0"/>
+          </a:p>
+        </p:txBody>
+      </p:sp>
+      <p:sp>
+        <p:nvSpPr>
+          <p:cNvPr id="27" name="Text 23"/>
+          <p:cNvSpPr/>
+          <p:nvPr/>
+        </p:nvSpPr>
+        <p:spPr>
+          <a:xfrm>
+            <a:off x="6278880" y="5376863"/>
+            <a:ext cx="5334000" cy="566261"/>
           </a:xfrm>
           <a:prstGeom prst="rect">
             <a:avLst/>
@@ -8914,62 +8881,20 @@
           <a:p>
             <a:pPr algn="l" indent="0" marL="0">
               <a:lnSpc>
-                <a:spcPts val="2480"/>
-              </a:lnSpc>
-              <a:buNone/>
-            </a:pPr>
-            <a:r>
-              <a:rPr lang="en-US" sz="1600" b="1" dirty="0">
-                <a:solidFill>
-                  <a:srgbClr val="18383F"/>
-                </a:solidFill>
-                <a:latin typeface="Microsoft YaHei" pitchFamily="34" charset="0"/>
-                <a:ea typeface="Microsoft YaHei" pitchFamily="34" charset="-122"/>
-                <a:cs typeface="Microsoft YaHei" pitchFamily="34" charset="-120"/>
-              </a:rPr>
-              <a:t>保持原始比例，避免单向拉伸</a:t>
-            </a:r>
-            <a:endParaRPr lang="en-US" sz="1600" dirty="0"/>
-          </a:p>
-        </p:txBody>
-      </p:sp>
-      <p:sp>
-        <p:nvSpPr>
-          <p:cNvPr id="30" name="Text 24"/>
-          <p:cNvSpPr/>
-          <p:nvPr/>
-        </p:nvSpPr>
-        <p:spPr>
-          <a:xfrm>
-            <a:off x="6294120" y="4853702"/>
-            <a:ext cx="5303520" cy="248841"/>
-          </a:xfrm>
-          <a:prstGeom prst="rect">
-            <a:avLst/>
-          </a:prstGeom>
-          <a:noFill/>
-          <a:ln/>
-        </p:spPr>
-        <p:txBody>
-          <a:bodyPr wrap="square" lIns="0" tIns="0" rIns="0" bIns="0" rtlCol="0" anchor="ctr"/>
-          <a:lstStyle/>
-          <a:p>
-            <a:pPr algn="l" indent="0" marL="0">
-              <a:lnSpc>
-                <a:spcPts val="1960"/>
+                <a:spcPts val="2170"/>
               </a:lnSpc>
               <a:buNone/>
             </a:pPr>
             <a:r>
               <a:rPr lang="en-US" sz="1400" dirty="0">
                 <a:solidFill>
-                  <a:srgbClr val="18383F"/>
-                </a:solidFill>
-                <a:latin typeface="Microsoft YaHei" pitchFamily="34" charset="0"/>
-                <a:ea typeface="Microsoft YaHei" pitchFamily="34" charset="-122"/>
-                <a:cs typeface="Microsoft YaHei" pitchFamily="34" charset="-120"/>
-              </a:rPr>
-              <a:t>PDF 显示视频静态帧；PPTX 可内嵌视频。</a:t>
+                  <a:srgbClr val="0F6674"/>
+                </a:solidFill>
+                <a:latin typeface="Microsoft YaHei" pitchFamily="34" charset="0"/>
+                <a:ea typeface="Microsoft YaHei" pitchFamily="34" charset="-122"/>
+                <a:cs typeface="Microsoft YaHei" pitchFamily="34" charset="-120"/>
+              </a:rPr>
+              <a:t>取景检查：保留图中关键标注与坐标；说明裁剪范围，确保不会改变原始证据的含义。</a:t>
             </a:r>
             <a:endParaRPr lang="en-US" sz="1400" dirty="0"/>
           </a:p>
@@ -8977,49 +8902,7 @@
       </p:sp>
       <p:sp>
         <p:nvSpPr>
-          <p:cNvPr id="31" name="Text 25"/>
-          <p:cNvSpPr/>
-          <p:nvPr/>
-        </p:nvSpPr>
-        <p:spPr>
-          <a:xfrm>
-            <a:off x="6431280" y="5362099"/>
-            <a:ext cx="5029200" cy="566261"/>
-          </a:xfrm>
-          <a:prstGeom prst="rect">
-            <a:avLst/>
-          </a:prstGeom>
-          <a:noFill/>
-          <a:ln/>
-        </p:spPr>
-        <p:txBody>
-          <a:bodyPr wrap="square" lIns="0" tIns="0" rIns="0" bIns="0" rtlCol="0" anchor="ctr"/>
-          <a:lstStyle/>
-          <a:p>
-            <a:pPr algn="l" indent="0" marL="0">
-              <a:lnSpc>
-                <a:spcPts val="2170"/>
-              </a:lnSpc>
-              <a:buNone/>
-            </a:pPr>
-            <a:r>
-              <a:rPr lang="en-US" sz="1400" dirty="0">
-                <a:solidFill>
-                  <a:srgbClr val="0F6674"/>
-                </a:solidFill>
-                <a:latin typeface="Microsoft YaHei" pitchFamily="34" charset="0"/>
-                <a:ea typeface="Microsoft YaHei" pitchFamily="34" charset="-122"/>
-                <a:cs typeface="Microsoft YaHei" pitchFamily="34" charset="-120"/>
-              </a:rPr>
-              <a:t>取景检查：保留图中关键标注与坐标；说明裁剪范围，确保不会改变原始证据的含义。</a:t>
-            </a:r>
-            <a:endParaRPr lang="en-US" sz="1400" dirty="0"/>
-          </a:p>
-        </p:txBody>
-      </p:sp>
-      <p:sp>
-        <p:nvSpPr>
-          <p:cNvPr id="32" name="Text 26"/>
+          <p:cNvPr id="28" name="Text 24"/>
           <p:cNvSpPr/>
           <p:nvPr/>
         </p:nvSpPr>
@@ -9061,7 +8944,7 @@
       </p:sp>
       <p:sp>
         <p:nvSpPr>
-          <p:cNvPr id="33" name="Text 27"/>
+          <p:cNvPr id="29" name="Text 25"/>
           <p:cNvSpPr/>
           <p:nvPr/>
         </p:nvSpPr>
@@ -9103,7 +8986,7 @@
       </p:sp>
       <p:sp>
         <p:nvSpPr>
-          <p:cNvPr id="34" name="Text 28"/>
+          <p:cNvPr id="30" name="Text 26"/>
           <p:cNvSpPr/>
           <p:nvPr/>
         </p:nvSpPr>
@@ -9145,7 +9028,7 @@
       </p:sp>
       <p:sp>
         <p:nvSpPr>
-          <p:cNvPr id="35" name="Shape 29"/>
+          <p:cNvPr id="31" name="Shape 27"/>
           <p:cNvSpPr/>
           <p:nvPr/>
         </p:nvSpPr>
@@ -46251,9 +46134,213 @@
           <a:chExt cx="0" cy="0"/>
         </a:xfrm>
       </p:grpSpPr>
+      <p:sp>
+        <p:nvSpPr>
+          <p:cNvPr id="3" name="Shape 0"/>
+          <p:cNvSpPr/>
+          <p:nvPr/>
+        </p:nvSpPr>
+        <p:spPr>
+          <a:xfrm>
+            <a:off x="0" y="0"/>
+            <a:ext cx="9753600" cy="53340"/>
+          </a:xfrm>
+          <a:prstGeom prst="rect">
+            <a:avLst/>
+          </a:prstGeom>
+          <a:solidFill>
+            <a:srgbClr val="0F6674"/>
+          </a:solidFill>
+          <a:ln w="12700">
+            <a:solidFill>
+              <a:srgbClr val="0F6674">
+                <a:alpha val="0"/>
+              </a:srgbClr>
+            </a:solidFill>
+            <a:prstDash val="solid"/>
+          </a:ln>
+        </p:spPr>
+      </p:sp>
+      <p:sp>
+        <p:nvSpPr>
+          <p:cNvPr id="4" name="Shape 1"/>
+          <p:cNvSpPr/>
+          <p:nvPr/>
+        </p:nvSpPr>
+        <p:spPr>
+          <a:xfrm>
+            <a:off x="9753600" y="0"/>
+            <a:ext cx="2438400" cy="53340"/>
+          </a:xfrm>
+          <a:prstGeom prst="rect">
+            <a:avLst/>
+          </a:prstGeom>
+          <a:solidFill>
+            <a:srgbClr val="0F6674"/>
+          </a:solidFill>
+          <a:ln w="12700">
+            <a:solidFill>
+              <a:srgbClr val="0F6674">
+                <a:alpha val="0"/>
+              </a:srgbClr>
+            </a:solidFill>
+            <a:prstDash val="solid"/>
+          </a:ln>
+        </p:spPr>
+      </p:sp>
+      <p:sp>
+        <p:nvSpPr>
+          <p:cNvPr id="5" name="Shape 2"/>
+          <p:cNvSpPr/>
+          <p:nvPr/>
+        </p:nvSpPr>
+        <p:spPr>
+          <a:xfrm>
+            <a:off x="441960" y="259080"/>
+            <a:ext cx="289560" cy="228600"/>
+          </a:xfrm>
+          <a:prstGeom prst="rect">
+            <a:avLst/>
+          </a:prstGeom>
+          <a:solidFill>
+            <a:srgbClr val="EDF6F5"/>
+          </a:solidFill>
+          <a:ln w="12700">
+            <a:solidFill>
+              <a:srgbClr val="EDF6F5">
+                <a:alpha val="0"/>
+              </a:srgbClr>
+            </a:solidFill>
+            <a:prstDash val="solid"/>
+          </a:ln>
+        </p:spPr>
+      </p:sp>
+      <p:sp>
+        <p:nvSpPr>
+          <p:cNvPr id="6" name="Text 3"/>
+          <p:cNvSpPr/>
+          <p:nvPr/>
+        </p:nvSpPr>
+        <p:spPr>
+          <a:xfrm>
+            <a:off x="480060" y="259080"/>
+            <a:ext cx="213360" cy="228600"/>
+          </a:xfrm>
+          <a:prstGeom prst="rect">
+            <a:avLst/>
+          </a:prstGeom>
+          <a:noFill/>
+          <a:ln/>
+        </p:spPr>
+        <p:txBody>
+          <a:bodyPr wrap="none" lIns="0" tIns="0" rIns="0" bIns="0" rtlCol="0" anchor="ctr"/>
+          <a:lstStyle/>
+          <a:p>
+            <a:pPr algn="l" indent="0" marL="0">
+              <a:buNone/>
+            </a:pPr>
+            <a:r>
+              <a:rPr lang="en-US" sz="1200" b="1" dirty="0">
+                <a:solidFill>
+                  <a:srgbClr val="0F6674"/>
+                </a:solidFill>
+                <a:latin typeface="Arial" pitchFamily="34" charset="0"/>
+                <a:ea typeface="Arial" pitchFamily="34" charset="-122"/>
+                <a:cs typeface="Arial" pitchFamily="34" charset="-120"/>
+              </a:rPr>
+              <a:t>01</a:t>
+            </a:r>
+            <a:endParaRPr lang="en-US" sz="1200" dirty="0"/>
+          </a:p>
+        </p:txBody>
+      </p:sp>
+      <p:sp>
+        <p:nvSpPr>
+          <p:cNvPr id="7" name="Text 4"/>
+          <p:cNvSpPr/>
+          <p:nvPr/>
+        </p:nvSpPr>
+        <p:spPr>
+          <a:xfrm>
+            <a:off x="838200" y="235625"/>
+            <a:ext cx="9768840" cy="275511"/>
+          </a:xfrm>
+          <a:prstGeom prst="rect">
+            <a:avLst/>
+          </a:prstGeom>
+          <a:noFill/>
+          <a:ln/>
+        </p:spPr>
+        <p:txBody>
+          <a:bodyPr wrap="none" lIns="0" tIns="0" rIns="0" bIns="0" rtlCol="0" anchor="ctr"/>
+          <a:lstStyle/>
+          <a:p>
+            <a:pPr algn="l" indent="0" marL="0">
+              <a:lnSpc>
+                <a:spcPts val="2170"/>
+              </a:lnSpc>
+              <a:buNone/>
+            </a:pPr>
+            <a:r>
+              <a:rPr lang="en-US" sz="1400" b="1" dirty="0">
+                <a:solidFill>
+                  <a:srgbClr val="0F6674"/>
+                </a:solidFill>
+                <a:latin typeface="Microsoft YaHei" pitchFamily="34" charset="0"/>
+                <a:ea typeface="Microsoft YaHei" pitchFamily="34" charset="-122"/>
+                <a:cs typeface="Microsoft YaHei" pitchFamily="34" charset="-120"/>
+              </a:rPr>
+              <a:t>制作起步</a:t>
+            </a:r>
+            <a:endParaRPr lang="en-US" sz="1400" dirty="0"/>
+          </a:p>
+        </p:txBody>
+      </p:sp>
+      <p:sp>
+        <p:nvSpPr>
+          <p:cNvPr id="8" name="Text 5"/>
+          <p:cNvSpPr/>
+          <p:nvPr/>
+        </p:nvSpPr>
+        <p:spPr>
+          <a:xfrm>
+            <a:off x="441960" y="609600"/>
+            <a:ext cx="10165080" cy="433864"/>
+          </a:xfrm>
+          <a:prstGeom prst="rect">
+            <a:avLst/>
+          </a:prstGeom>
+          <a:noFill/>
+          <a:ln/>
+        </p:spPr>
+        <p:txBody>
+          <a:bodyPr wrap="none" lIns="0" tIns="0" rIns="0" bIns="0" rtlCol="0" anchor="ctr"/>
+          <a:lstStyle/>
+          <a:p>
+            <a:pPr algn="l" indent="0" marL="0">
+              <a:lnSpc>
+                <a:spcPts val="3416"/>
+              </a:lnSpc>
+              <a:buNone/>
+            </a:pPr>
+            <a:r>
+              <a:rPr lang="en-US" sz="2800" b="1" dirty="0">
+                <a:solidFill>
+                  <a:srgbClr val="0F6674"/>
+                </a:solidFill>
+                <a:latin typeface="Microsoft YaHei" pitchFamily="34" charset="0"/>
+                <a:ea typeface="Microsoft YaHei" pitchFamily="34" charset="-122"/>
+                <a:cs typeface="Microsoft YaHei" pitchFamily="34" charset="-120"/>
+              </a:rPr>
+              <a:t>学校概况与办学沿革</a:t>
+            </a:r>
+            <a:endParaRPr lang="en-US" sz="2800" dirty="0"/>
+          </a:p>
+        </p:txBody>
+      </p:sp>
       <p:pic>
         <p:nvPicPr>
-          <p:cNvPr id="3" name="Image 0" descr="preencoded.png">    </p:cNvPr>
+          <p:cNvPr id="9" name="Image 0" descr="preencoded.png">    </p:cNvPr>
           <p:cNvPicPr>
             <a:picLocks noChangeAspect="1"/>
           </p:cNvPicPr>
@@ -46267,8 +46354,8 @@
         </p:blipFill>
         <p:spPr>
           <a:xfrm>
-            <a:off x="0" y="0"/>
-            <a:ext cx="12192000" cy="6858000"/>
+            <a:off x="10835640" y="201930"/>
+            <a:ext cx="914400" cy="914400"/>
           </a:xfrm>
           <a:prstGeom prst="rect">
             <a:avLst/>
@@ -46277,130 +46364,76 @@
       </p:pic>
       <p:sp>
         <p:nvSpPr>
-          <p:cNvPr id="4" name="Text 0"/>
-          <p:cNvSpPr/>
-          <p:nvPr/>
-        </p:nvSpPr>
-        <p:spPr>
-          <a:xfrm>
-            <a:off x="480060" y="259080"/>
-            <a:ext cx="213360" cy="228600"/>
-          </a:xfrm>
-          <a:prstGeom prst="rect">
-            <a:avLst/>
-          </a:prstGeom>
-          <a:noFill/>
-          <a:ln/>
-        </p:spPr>
-        <p:txBody>
-          <a:bodyPr wrap="none" lIns="0" tIns="0" rIns="0" bIns="0" rtlCol="0" anchor="ctr"/>
+          <p:cNvPr id="10" name="Shape 6"/>
+          <p:cNvSpPr/>
+          <p:nvPr/>
+        </p:nvSpPr>
+        <p:spPr>
+          <a:xfrm>
+            <a:off x="441960" y="1264920"/>
+            <a:ext cx="11308080" cy="15240"/>
+          </a:xfrm>
+          <a:prstGeom prst="rect">
+            <a:avLst/>
+          </a:prstGeom>
+          <a:solidFill>
+            <a:srgbClr val="0F6674"/>
+          </a:solidFill>
+          <a:ln w="12700">
+            <a:solidFill>
+              <a:srgbClr val="0F6674">
+                <a:alpha val="0"/>
+              </a:srgbClr>
+            </a:solidFill>
+            <a:prstDash val="solid"/>
+          </a:ln>
+        </p:spPr>
+      </p:sp>
+      <p:sp>
+        <p:nvSpPr>
+          <p:cNvPr id="11" name="Text 7"/>
+          <p:cNvSpPr/>
+          <p:nvPr/>
+        </p:nvSpPr>
+        <p:spPr>
+          <a:xfrm>
+            <a:off x="441960" y="1463040"/>
+            <a:ext cx="11308080" cy="629841"/>
+          </a:xfrm>
+          <a:prstGeom prst="rect">
+            <a:avLst/>
+          </a:prstGeom>
+          <a:noFill/>
+          <a:ln/>
+        </p:spPr>
+        <p:txBody>
+          <a:bodyPr wrap="square" lIns="0" tIns="0" rIns="0" bIns="0" rtlCol="0" anchor="ctr"/>
           <a:lstStyle/>
           <a:p>
             <a:pPr algn="l" indent="0" marL="0">
-              <a:buNone/>
-            </a:pPr>
-            <a:r>
-              <a:rPr lang="en-US" sz="1200" b="1" dirty="0">
-                <a:solidFill>
-                  <a:srgbClr val="0F6674"/>
-                </a:solidFill>
-                <a:latin typeface="Arial" pitchFamily="34" charset="0"/>
-                <a:ea typeface="Arial" pitchFamily="34" charset="-122"/>
-                <a:cs typeface="Arial" pitchFamily="34" charset="-120"/>
-              </a:rPr>
-              <a:t>01</a:t>
-            </a:r>
-            <a:endParaRPr lang="en-US" sz="1200" dirty="0"/>
-          </a:p>
-        </p:txBody>
-      </p:sp>
-      <p:sp>
-        <p:nvSpPr>
-          <p:cNvPr id="5" name="Text 1"/>
-          <p:cNvSpPr/>
-          <p:nvPr/>
-        </p:nvSpPr>
-        <p:spPr>
-          <a:xfrm>
-            <a:off x="838200" y="235625"/>
-            <a:ext cx="9768840" cy="275511"/>
-          </a:xfrm>
-          <a:prstGeom prst="rect">
-            <a:avLst/>
-          </a:prstGeom>
-          <a:noFill/>
-          <a:ln/>
-        </p:spPr>
-        <p:txBody>
-          <a:bodyPr wrap="none" lIns="0" tIns="0" rIns="0" bIns="0" rtlCol="0" anchor="ctr"/>
-          <a:lstStyle/>
-          <a:p>
-            <a:pPr algn="l" indent="0" marL="0">
-              <a:lnSpc>
-                <a:spcPts val="2170"/>
-              </a:lnSpc>
-              <a:buNone/>
-            </a:pPr>
-            <a:r>
-              <a:rPr lang="en-US" sz="1400" b="1" dirty="0">
-                <a:solidFill>
-                  <a:srgbClr val="40647D"/>
-                </a:solidFill>
-                <a:latin typeface="Microsoft YaHei" pitchFamily="34" charset="0"/>
-                <a:ea typeface="Microsoft YaHei" pitchFamily="34" charset="-122"/>
-                <a:cs typeface="Microsoft YaHei" pitchFamily="34" charset="-120"/>
-              </a:rPr>
-              <a:t>制作起步</a:t>
-            </a:r>
-            <a:endParaRPr lang="en-US" sz="1400" dirty="0"/>
-          </a:p>
-        </p:txBody>
-      </p:sp>
-      <p:sp>
-        <p:nvSpPr>
-          <p:cNvPr id="6" name="Text 2"/>
-          <p:cNvSpPr/>
-          <p:nvPr/>
-        </p:nvSpPr>
-        <p:spPr>
-          <a:xfrm>
-            <a:off x="441960" y="609600"/>
-            <a:ext cx="10165080" cy="433864"/>
-          </a:xfrm>
-          <a:prstGeom prst="rect">
-            <a:avLst/>
-          </a:prstGeom>
-          <a:noFill/>
-          <a:ln/>
-        </p:spPr>
-        <p:txBody>
-          <a:bodyPr wrap="none" lIns="0" tIns="0" rIns="0" bIns="0" rtlCol="0" anchor="ctr"/>
-          <a:lstStyle/>
-          <a:p>
-            <a:pPr algn="l" indent="0" marL="0">
-              <a:lnSpc>
-                <a:spcPts val="3416"/>
-              </a:lnSpc>
-              <a:buNone/>
-            </a:pPr>
-            <a:r>
-              <a:rPr lang="en-US" sz="2800" b="1" dirty="0">
-                <a:solidFill>
-                  <a:srgbClr val="0F6674"/>
-                </a:solidFill>
-                <a:latin typeface="Microsoft YaHei" pitchFamily="34" charset="0"/>
-                <a:ea typeface="Microsoft YaHei" pitchFamily="34" charset="-122"/>
-                <a:cs typeface="Microsoft YaHei" pitchFamily="34" charset="-120"/>
-              </a:rPr>
-              <a:t>学校概况与办学沿革</a:t>
-            </a:r>
-            <a:endParaRPr lang="en-US" sz="2800" dirty="0"/>
+              <a:lnSpc>
+                <a:spcPts val="2480"/>
+              </a:lnSpc>
+              <a:buNone/>
+            </a:pPr>
+            <a:r>
+              <a:rPr lang="en-US" sz="1600" dirty="0">
+                <a:solidFill>
+                  <a:srgbClr val="18383F"/>
+                </a:solidFill>
+                <a:latin typeface="Microsoft YaHei" pitchFamily="34" charset="0"/>
+                <a:ea typeface="Microsoft YaHei" pitchFamily="34" charset="-122"/>
+                <a:cs typeface="Microsoft YaHei" pitchFamily="34" charset="-120"/>
+              </a:rPr>
+              <a:t>从处州师范学堂到丽水学院，学校坚持“明德笃行”，在师范教育基础上拓展多学科办学，面向地方需求推进应用型人才培养与科研服务。</a:t>
+            </a:r>
+            <a:endParaRPr lang="en-US" sz="1600" dirty="0"/>
           </a:p>
         </p:txBody>
       </p:sp>
       <p:pic>
         <p:nvPicPr>
-          <p:cNvPr id="7" name="Image 1" descr="preencoded.png">    </p:cNvPr>
+          <p:cNvPr id="12" name="Image 1" descr="preencoded.png">    </p:cNvPr>
           <p:cNvPicPr>
             <a:picLocks noChangeAspect="1"/>
           </p:cNvPicPr>
@@ -46414,8 +46447,8 @@
         </p:blipFill>
         <p:spPr>
           <a:xfrm>
-            <a:off x="10835640" y="201930"/>
-            <a:ext cx="914400" cy="914400"/>
+            <a:off x="441960" y="5730240"/>
+            <a:ext cx="11308080" cy="472440"/>
           </a:xfrm>
           <a:prstGeom prst="rect">
             <a:avLst/>
@@ -46424,55 +46457,67 @@
       </p:pic>
       <p:sp>
         <p:nvSpPr>
-          <p:cNvPr id="8" name="Text 3"/>
-          <p:cNvSpPr/>
-          <p:nvPr/>
-        </p:nvSpPr>
-        <p:spPr>
-          <a:xfrm>
-            <a:off x="441960" y="1463040"/>
-            <a:ext cx="11308080" cy="629841"/>
-          </a:xfrm>
-          <a:prstGeom prst="rect">
-            <a:avLst/>
-          </a:prstGeom>
-          <a:noFill/>
-          <a:ln/>
-        </p:spPr>
-        <p:txBody>
-          <a:bodyPr wrap="square" lIns="0" tIns="0" rIns="0" bIns="0" rtlCol="0" anchor="ctr"/>
-          <a:lstStyle/>
-          <a:p>
-            <a:pPr algn="l" indent="0" marL="0">
-              <a:lnSpc>
-                <a:spcPts val="2480"/>
-              </a:lnSpc>
-              <a:buNone/>
-            </a:pPr>
-            <a:r>
-              <a:rPr lang="en-US" sz="1600" dirty="0">
-                <a:solidFill>
-                  <a:srgbClr val="18383F"/>
-                </a:solidFill>
-                <a:latin typeface="Microsoft YaHei" pitchFamily="34" charset="0"/>
-                <a:ea typeface="Microsoft YaHei" pitchFamily="34" charset="-122"/>
-                <a:cs typeface="Microsoft YaHei" pitchFamily="34" charset="-120"/>
-              </a:rPr>
-              <a:t>从处州师范学堂到丽水学院，学校坚持“明德笃行”，在师范教育基础上拓展多学科办学，面向地方需求推进应用型人才培养与科研服务。</a:t>
-            </a:r>
-            <a:endParaRPr lang="en-US" sz="1600" dirty="0"/>
-          </a:p>
-        </p:txBody>
-      </p:sp>
-      <p:sp>
-        <p:nvSpPr>
-          <p:cNvPr id="9" name="Text 4"/>
-          <p:cNvSpPr/>
-          <p:nvPr/>
-        </p:nvSpPr>
-        <p:spPr>
-          <a:xfrm>
-            <a:off x="807720" y="2306241"/>
+          <p:cNvPr id="13" name="Shape 8"/>
+          <p:cNvSpPr/>
+          <p:nvPr/>
+        </p:nvSpPr>
+        <p:spPr>
+          <a:xfrm>
+            <a:off x="685800" y="2331720"/>
+            <a:ext cx="2613660" cy="3276600"/>
+          </a:xfrm>
+          <a:prstGeom prst="rect">
+            <a:avLst/>
+          </a:prstGeom>
+          <a:solidFill>
+            <a:srgbClr val="EDF6F5"/>
+          </a:solidFill>
+          <a:ln w="12700">
+            <a:solidFill>
+              <a:srgbClr val="EDF6F5">
+                <a:alpha val="0"/>
+              </a:srgbClr>
+            </a:solidFill>
+            <a:prstDash val="solid"/>
+          </a:ln>
+        </p:spPr>
+      </p:sp>
+      <p:sp>
+        <p:nvSpPr>
+          <p:cNvPr id="14" name="Shape 9"/>
+          <p:cNvSpPr/>
+          <p:nvPr/>
+        </p:nvSpPr>
+        <p:spPr>
+          <a:xfrm>
+            <a:off x="685800" y="2331720"/>
+            <a:ext cx="2613660" cy="441960"/>
+          </a:xfrm>
+          <a:prstGeom prst="rect">
+            <a:avLst/>
+          </a:prstGeom>
+          <a:solidFill>
+            <a:srgbClr val="0F6674"/>
+          </a:solidFill>
+          <a:ln w="12700">
+            <a:solidFill>
+              <a:srgbClr val="0F6674">
+                <a:alpha val="0"/>
+              </a:srgbClr>
+            </a:solidFill>
+            <a:prstDash val="solid"/>
+          </a:ln>
+        </p:spPr>
+      </p:sp>
+      <p:sp>
+        <p:nvSpPr>
+          <p:cNvPr id="15" name="Text 10"/>
+          <p:cNvSpPr/>
+          <p:nvPr/>
+        </p:nvSpPr>
+        <p:spPr>
+          <a:xfrm>
+            <a:off x="807720" y="2377440"/>
             <a:ext cx="2369820" cy="350520"/>
           </a:xfrm>
           <a:prstGeom prst="rect">
@@ -46508,7 +46553,7 @@
       </p:sp>
       <p:pic>
         <p:nvPicPr>
-          <p:cNvPr id="10" name="Image 2" descr="preencoded.png">    </p:cNvPr>
+          <p:cNvPr id="16" name="Image 2" descr="preencoded.png">    </p:cNvPr>
           <p:cNvPicPr>
             <a:picLocks noChangeAspect="1"/>
           </p:cNvPicPr>
@@ -46522,8 +46567,8 @@
         </p:blipFill>
         <p:spPr>
           <a:xfrm>
-            <a:off x="807720" y="2824401"/>
-            <a:ext cx="2369820" cy="1127760"/>
+            <a:off x="807720" y="2895600"/>
+            <a:ext cx="2369820" cy="1155978"/>
           </a:xfrm>
           <a:prstGeom prst="rect">
             <a:avLst/>
@@ -46532,14 +46577,14 @@
       </p:pic>
       <p:sp>
         <p:nvSpPr>
-          <p:cNvPr id="11" name="Text 5"/>
-          <p:cNvSpPr/>
-          <p:nvPr/>
-        </p:nvSpPr>
-        <p:spPr>
-          <a:xfrm>
-            <a:off x="807720" y="4150281"/>
-            <a:ext cx="2369820" cy="1381839"/>
+          <p:cNvPr id="17" name="Text 11"/>
+          <p:cNvSpPr/>
+          <p:nvPr/>
+        </p:nvSpPr>
+        <p:spPr>
+          <a:xfrm>
+            <a:off x="807720" y="4173498"/>
+            <a:ext cx="2369820" cy="1343382"/>
           </a:xfrm>
           <a:prstGeom prst="rect">
             <a:avLst/>
@@ -46574,14 +46619,14 @@
       </p:sp>
       <p:sp>
         <p:nvSpPr>
-          <p:cNvPr id="12" name="Text 6"/>
-          <p:cNvSpPr/>
-          <p:nvPr/>
-        </p:nvSpPr>
-        <p:spPr>
-          <a:xfrm>
-            <a:off x="3543300" y="2306241"/>
-            <a:ext cx="2369820" cy="350520"/>
+          <p:cNvPr id="18" name="Text 12"/>
+          <p:cNvSpPr/>
+          <p:nvPr/>
+        </p:nvSpPr>
+        <p:spPr>
+          <a:xfrm>
+            <a:off x="838200" y="5823585"/>
+            <a:ext cx="1371600" cy="285750"/>
           </a:xfrm>
           <a:prstGeom prst="rect">
             <a:avLst/>
@@ -46595,28 +46640,28 @@
           <a:p>
             <a:pPr algn="l" indent="0" marL="0">
               <a:lnSpc>
-                <a:spcPts val="2760"/>
-              </a:lnSpc>
-              <a:buNone/>
-            </a:pPr>
-            <a:r>
-              <a:rPr lang="en-US" sz="2400" b="1" dirty="0">
-                <a:solidFill>
-                  <a:srgbClr val="FFFFFF"/>
-                </a:solidFill>
-                <a:latin typeface="Microsoft YaHei" pitchFamily="34" charset="0"/>
-                <a:ea typeface="Microsoft YaHei" pitchFamily="34" charset="-122"/>
-                <a:cs typeface="Microsoft YaHei" pitchFamily="34" charset="-120"/>
-              </a:rPr>
-              <a:t>1946年</a:t>
-            </a:r>
-            <a:endParaRPr lang="en-US" sz="2400" dirty="0"/>
+                <a:spcPts val="2250"/>
+              </a:lnSpc>
+              <a:buNone/>
+            </a:pPr>
+            <a:r>
+              <a:rPr lang="en-US" sz="1800" b="1" dirty="0">
+                <a:solidFill>
+                  <a:srgbClr val="0F6674"/>
+                </a:solidFill>
+                <a:latin typeface="Microsoft YaHei" pitchFamily="34" charset="0"/>
+                <a:ea typeface="Microsoft YaHei" pitchFamily="34" charset="-122"/>
+                <a:cs typeface="Microsoft YaHei" pitchFamily="34" charset="-120"/>
+              </a:rPr>
+              <a:t>师范薪火初传</a:t>
+            </a:r>
+            <a:endParaRPr lang="en-US" sz="1800" dirty="0"/>
           </a:p>
         </p:txBody>
       </p:sp>
       <p:pic>
         <p:nvPicPr>
-          <p:cNvPr id="13" name="Image 3" descr="preencoded.png">    </p:cNvPr>
+          <p:cNvPr id="19" name="Image 3" descr="preencoded.png">    </p:cNvPr>
           <p:cNvPicPr>
             <a:picLocks noChangeAspect="1"/>
           </p:cNvPicPr>
@@ -46630,101 +46675,17 @@
         </p:blipFill>
         <p:spPr>
           <a:xfrm>
-            <a:off x="3543300" y="2824401"/>
-            <a:ext cx="2369820" cy="1127760"/>
+            <a:off x="670560" y="2331720"/>
+            <a:ext cx="30480" cy="3634740"/>
           </a:xfrm>
           <a:prstGeom prst="rect">
             <a:avLst/>
           </a:prstGeom>
         </p:spPr>
       </p:pic>
-      <p:sp>
-        <p:nvSpPr>
-          <p:cNvPr id="14" name="Text 7"/>
-          <p:cNvSpPr/>
-          <p:nvPr/>
-        </p:nvSpPr>
-        <p:spPr>
-          <a:xfrm>
-            <a:off x="3543300" y="4150281"/>
-            <a:ext cx="2369820" cy="1381839"/>
-          </a:xfrm>
-          <a:prstGeom prst="rect">
-            <a:avLst/>
-          </a:prstGeom>
-          <a:noFill/>
-          <a:ln/>
-        </p:spPr>
-        <p:txBody>
-          <a:bodyPr wrap="square" lIns="0" tIns="0" rIns="0" bIns="0" rtlCol="0" anchor="ctr"/>
-          <a:lstStyle/>
-          <a:p>
-            <a:pPr algn="just" indent="0" marL="0">
-              <a:lnSpc>
-                <a:spcPts val="2100"/>
-              </a:lnSpc>
-              <a:buNone/>
-            </a:pPr>
-            <a:r>
-              <a:rPr lang="en-US" sz="1400" dirty="0">
-                <a:solidFill>
-                  <a:srgbClr val="18383F"/>
-                </a:solidFill>
-                <a:latin typeface="Microsoft YaHei" pitchFamily="34" charset="0"/>
-                <a:ea typeface="Microsoft YaHei" pitchFamily="34" charset="-122"/>
-                <a:cs typeface="Microsoft YaHei" pitchFamily="34" charset="-120"/>
-              </a:rPr>
-              <a:t>抗战胜利后，在云和重建浙江省处州师范学校。此后迁回丽水，在办学条件恢复中延续师范教育传统与人才培养。</a:t>
-            </a:r>
-            <a:endParaRPr lang="en-US" sz="1400" dirty="0"/>
-          </a:p>
-        </p:txBody>
-      </p:sp>
-      <p:sp>
-        <p:nvSpPr>
-          <p:cNvPr id="15" name="Text 8"/>
-          <p:cNvSpPr/>
-          <p:nvPr/>
-        </p:nvSpPr>
-        <p:spPr>
-          <a:xfrm>
-            <a:off x="6278880" y="2306241"/>
-            <a:ext cx="2369820" cy="350520"/>
-          </a:xfrm>
-          <a:prstGeom prst="rect">
-            <a:avLst/>
-          </a:prstGeom>
-          <a:noFill/>
-          <a:ln/>
-        </p:spPr>
-        <p:txBody>
-          <a:bodyPr wrap="square" lIns="0" tIns="0" rIns="0" bIns="0" rtlCol="0" anchor="ctr"/>
-          <a:lstStyle/>
-          <a:p>
-            <a:pPr algn="l" indent="0" marL="0">
-              <a:lnSpc>
-                <a:spcPts val="2760"/>
-              </a:lnSpc>
-              <a:buNone/>
-            </a:pPr>
-            <a:r>
-              <a:rPr lang="en-US" sz="2400" b="1" dirty="0">
-                <a:solidFill>
-                  <a:srgbClr val="FFFFFF"/>
-                </a:solidFill>
-                <a:latin typeface="Microsoft YaHei" pitchFamily="34" charset="0"/>
-                <a:ea typeface="Microsoft YaHei" pitchFamily="34" charset="-122"/>
-                <a:cs typeface="Microsoft YaHei" pitchFamily="34" charset="-120"/>
-              </a:rPr>
-              <a:t>2004年</a:t>
-            </a:r>
-            <a:endParaRPr lang="en-US" sz="2400" dirty="0"/>
-          </a:p>
-        </p:txBody>
-      </p:sp>
       <p:pic>
         <p:nvPicPr>
-          <p:cNvPr id="16" name="Image 4" descr="preencoded.png">    </p:cNvPr>
+          <p:cNvPr id="20" name="Image 4" descr="preencoded.png">    </p:cNvPr>
           <p:cNvPicPr>
             <a:picLocks noChangeAspect="1"/>
           </p:cNvPicPr>
@@ -46738,8 +46699,8 @@
         </p:blipFill>
         <p:spPr>
           <a:xfrm>
-            <a:off x="6278880" y="2824401"/>
-            <a:ext cx="2369820" cy="1127760"/>
+            <a:off x="594360" y="5875020"/>
+            <a:ext cx="182880" cy="182880"/>
           </a:xfrm>
           <a:prstGeom prst="rect">
             <a:avLst/>
@@ -46748,55 +46709,67 @@
       </p:pic>
       <p:sp>
         <p:nvSpPr>
-          <p:cNvPr id="17" name="Text 9"/>
-          <p:cNvSpPr/>
-          <p:nvPr/>
-        </p:nvSpPr>
-        <p:spPr>
-          <a:xfrm>
-            <a:off x="6278880" y="4150281"/>
-            <a:ext cx="2369820" cy="1381839"/>
-          </a:xfrm>
-          <a:prstGeom prst="rect">
-            <a:avLst/>
-          </a:prstGeom>
-          <a:noFill/>
-          <a:ln/>
-        </p:spPr>
-        <p:txBody>
-          <a:bodyPr wrap="square" lIns="0" tIns="0" rIns="0" bIns="0" rtlCol="0" anchor="ctr"/>
-          <a:lstStyle/>
-          <a:p>
-            <a:pPr algn="just" indent="0" marL="0">
-              <a:lnSpc>
-                <a:spcPts val="2100"/>
-              </a:lnSpc>
-              <a:buNone/>
-            </a:pPr>
-            <a:r>
-              <a:rPr lang="en-US" sz="1400" dirty="0">
-                <a:solidFill>
-                  <a:srgbClr val="18383F"/>
-                </a:solidFill>
-                <a:latin typeface="Microsoft YaHei" pitchFamily="34" charset="0"/>
-                <a:ea typeface="Microsoft YaHei" pitchFamily="34" charset="-122"/>
-                <a:cs typeface="Microsoft YaHei" pitchFamily="34" charset="-120"/>
-              </a:rPr>
-              <a:t>经教育部批准，学校升格更名为丽水学院。在原有办学基础上拓展本科教育，逐步形成多学科协调发展的格局。</a:t>
-            </a:r>
-            <a:endParaRPr lang="en-US" sz="1400" dirty="0"/>
-          </a:p>
-        </p:txBody>
-      </p:sp>
-      <p:sp>
-        <p:nvSpPr>
-          <p:cNvPr id="18" name="Text 10"/>
-          <p:cNvSpPr/>
-          <p:nvPr/>
-        </p:nvSpPr>
-        <p:spPr>
-          <a:xfrm>
-            <a:off x="9014460" y="2306241"/>
+          <p:cNvPr id="21" name="Shape 13"/>
+          <p:cNvSpPr/>
+          <p:nvPr/>
+        </p:nvSpPr>
+        <p:spPr>
+          <a:xfrm>
+            <a:off x="3421380" y="2331720"/>
+            <a:ext cx="2613660" cy="3276600"/>
+          </a:xfrm>
+          <a:prstGeom prst="rect">
+            <a:avLst/>
+          </a:prstGeom>
+          <a:solidFill>
+            <a:srgbClr val="EDF6F5"/>
+          </a:solidFill>
+          <a:ln w="12700">
+            <a:solidFill>
+              <a:srgbClr val="EDF6F5">
+                <a:alpha val="0"/>
+              </a:srgbClr>
+            </a:solidFill>
+            <a:prstDash val="solid"/>
+          </a:ln>
+        </p:spPr>
+      </p:sp>
+      <p:sp>
+        <p:nvSpPr>
+          <p:cNvPr id="22" name="Shape 14"/>
+          <p:cNvSpPr/>
+          <p:nvPr/>
+        </p:nvSpPr>
+        <p:spPr>
+          <a:xfrm>
+            <a:off x="3421380" y="2331720"/>
+            <a:ext cx="2613660" cy="441960"/>
+          </a:xfrm>
+          <a:prstGeom prst="rect">
+            <a:avLst/>
+          </a:prstGeom>
+          <a:solidFill>
+            <a:srgbClr val="0F6674"/>
+          </a:solidFill>
+          <a:ln w="12700">
+            <a:solidFill>
+              <a:srgbClr val="0F6674">
+                <a:alpha val="0"/>
+              </a:srgbClr>
+            </a:solidFill>
+            <a:prstDash val="solid"/>
+          </a:ln>
+        </p:spPr>
+      </p:sp>
+      <p:sp>
+        <p:nvSpPr>
+          <p:cNvPr id="23" name="Text 15"/>
+          <p:cNvSpPr/>
+          <p:nvPr/>
+        </p:nvSpPr>
+        <p:spPr>
+          <a:xfrm>
+            <a:off x="3543300" y="2377440"/>
             <a:ext cx="2369820" cy="350520"/>
           </a:xfrm>
           <a:prstGeom prst="rect">
@@ -46824,7 +46797,7 @@
                 <a:ea typeface="Microsoft YaHei" pitchFamily="34" charset="-122"/>
                 <a:cs typeface="Microsoft YaHei" pitchFamily="34" charset="-120"/>
               </a:rPr>
-              <a:t>新时代</a:t>
+              <a:t>1946年</a:t>
             </a:r>
             <a:endParaRPr lang="en-US" sz="2400" dirty="0"/>
           </a:p>
@@ -46832,7 +46805,7 @@
       </p:sp>
       <p:pic>
         <p:nvPicPr>
-          <p:cNvPr id="19" name="Image 5" descr="preencoded.png">    </p:cNvPr>
+          <p:cNvPr id="24" name="Image 5" descr="preencoded.png">    </p:cNvPr>
           <p:cNvPicPr>
             <a:picLocks noChangeAspect="1"/>
           </p:cNvPicPr>
@@ -46846,8 +46819,8 @@
         </p:blipFill>
         <p:spPr>
           <a:xfrm>
-            <a:off x="9014460" y="2824401"/>
-            <a:ext cx="2369820" cy="1127760"/>
+            <a:off x="3543300" y="2895600"/>
+            <a:ext cx="2369820" cy="1155978"/>
           </a:xfrm>
           <a:prstGeom prst="rect">
             <a:avLst/>
@@ -46856,14 +46829,14 @@
       </p:pic>
       <p:sp>
         <p:nvSpPr>
-          <p:cNvPr id="20" name="Text 11"/>
-          <p:cNvSpPr/>
-          <p:nvPr/>
-        </p:nvSpPr>
-        <p:spPr>
-          <a:xfrm>
-            <a:off x="9014460" y="4150281"/>
-            <a:ext cx="2369820" cy="1381839"/>
+          <p:cNvPr id="25" name="Text 16"/>
+          <p:cNvSpPr/>
+          <p:nvPr/>
+        </p:nvSpPr>
+        <p:spPr>
+          <a:xfrm>
+            <a:off x="3543300" y="4173498"/>
+            <a:ext cx="2369820" cy="1343382"/>
           </a:xfrm>
           <a:prstGeom prst="rect">
             <a:avLst/>
@@ -46890,6 +46863,510 @@
                 <a:ea typeface="Microsoft YaHei" pitchFamily="34" charset="-122"/>
                 <a:cs typeface="Microsoft YaHei" pitchFamily="34" charset="-120"/>
               </a:rPr>
+              <a:t>抗战胜利后，在云和重建浙江省处州师范学校。此后迁回丽水，在办学条件恢复中延续师范教育传统与人才培养。</a:t>
+            </a:r>
+            <a:endParaRPr lang="en-US" sz="1400" dirty="0"/>
+          </a:p>
+        </p:txBody>
+      </p:sp>
+      <p:sp>
+        <p:nvSpPr>
+          <p:cNvPr id="26" name="Text 17"/>
+          <p:cNvSpPr/>
+          <p:nvPr/>
+        </p:nvSpPr>
+        <p:spPr>
+          <a:xfrm>
+            <a:off x="3573780" y="5823585"/>
+            <a:ext cx="1371600" cy="285750"/>
+          </a:xfrm>
+          <a:prstGeom prst="rect">
+            <a:avLst/>
+          </a:prstGeom>
+          <a:noFill/>
+          <a:ln/>
+        </p:spPr>
+        <p:txBody>
+          <a:bodyPr wrap="square" lIns="0" tIns="0" rIns="0" bIns="0" rtlCol="0" anchor="ctr"/>
+          <a:lstStyle/>
+          <a:p>
+            <a:pPr algn="l" indent="0" marL="0">
+              <a:lnSpc>
+                <a:spcPts val="2250"/>
+              </a:lnSpc>
+              <a:buNone/>
+            </a:pPr>
+            <a:r>
+              <a:rPr lang="en-US" sz="1800" b="1" dirty="0">
+                <a:solidFill>
+                  <a:srgbClr val="0F6674"/>
+                </a:solidFill>
+                <a:latin typeface="Microsoft YaHei" pitchFamily="34" charset="0"/>
+                <a:ea typeface="Microsoft YaHei" pitchFamily="34" charset="-122"/>
+                <a:cs typeface="Microsoft YaHei" pitchFamily="34" charset="-120"/>
+              </a:rPr>
+              <a:t>重建延续文脉</a:t>
+            </a:r>
+            <a:endParaRPr lang="en-US" sz="1800" dirty="0"/>
+          </a:p>
+        </p:txBody>
+      </p:sp>
+      <p:pic>
+        <p:nvPicPr>
+          <p:cNvPr id="27" name="Image 6" descr="preencoded.png">    </p:cNvPr>
+          <p:cNvPicPr>
+            <a:picLocks noChangeAspect="1"/>
+          </p:cNvPicPr>
+          <p:nvPr/>
+        </p:nvPicPr>
+        <p:blipFill>
+          <a:blip r:embed="rId7"/>
+          <a:stretch>
+            <a:fillRect/>
+          </a:stretch>
+        </p:blipFill>
+        <p:spPr>
+          <a:xfrm>
+            <a:off x="3406140" y="2331720"/>
+            <a:ext cx="30480" cy="3634740"/>
+          </a:xfrm>
+          <a:prstGeom prst="rect">
+            <a:avLst/>
+          </a:prstGeom>
+        </p:spPr>
+      </p:pic>
+      <p:pic>
+        <p:nvPicPr>
+          <p:cNvPr id="28" name="Image 7" descr="preencoded.png">    </p:cNvPr>
+          <p:cNvPicPr>
+            <a:picLocks noChangeAspect="1"/>
+          </p:cNvPicPr>
+          <p:nvPr/>
+        </p:nvPicPr>
+        <p:blipFill>
+          <a:blip r:embed="rId8"/>
+          <a:stretch>
+            <a:fillRect/>
+          </a:stretch>
+        </p:blipFill>
+        <p:spPr>
+          <a:xfrm>
+            <a:off x="3329940" y="5875020"/>
+            <a:ext cx="182880" cy="182880"/>
+          </a:xfrm>
+          <a:prstGeom prst="rect">
+            <a:avLst/>
+          </a:prstGeom>
+        </p:spPr>
+      </p:pic>
+      <p:sp>
+        <p:nvSpPr>
+          <p:cNvPr id="29" name="Shape 18"/>
+          <p:cNvSpPr/>
+          <p:nvPr/>
+        </p:nvSpPr>
+        <p:spPr>
+          <a:xfrm>
+            <a:off x="6156960" y="2331720"/>
+            <a:ext cx="2613660" cy="3276600"/>
+          </a:xfrm>
+          <a:prstGeom prst="rect">
+            <a:avLst/>
+          </a:prstGeom>
+          <a:solidFill>
+            <a:srgbClr val="EDF6F5"/>
+          </a:solidFill>
+          <a:ln w="12700">
+            <a:solidFill>
+              <a:srgbClr val="EDF6F5">
+                <a:alpha val="0"/>
+              </a:srgbClr>
+            </a:solidFill>
+            <a:prstDash val="solid"/>
+          </a:ln>
+        </p:spPr>
+      </p:sp>
+      <p:sp>
+        <p:nvSpPr>
+          <p:cNvPr id="30" name="Shape 19"/>
+          <p:cNvSpPr/>
+          <p:nvPr/>
+        </p:nvSpPr>
+        <p:spPr>
+          <a:xfrm>
+            <a:off x="6156960" y="2331720"/>
+            <a:ext cx="2613660" cy="441960"/>
+          </a:xfrm>
+          <a:prstGeom prst="rect">
+            <a:avLst/>
+          </a:prstGeom>
+          <a:solidFill>
+            <a:srgbClr val="0F6674"/>
+          </a:solidFill>
+          <a:ln w="12700">
+            <a:solidFill>
+              <a:srgbClr val="0F6674">
+                <a:alpha val="0"/>
+              </a:srgbClr>
+            </a:solidFill>
+            <a:prstDash val="solid"/>
+          </a:ln>
+        </p:spPr>
+      </p:sp>
+      <p:sp>
+        <p:nvSpPr>
+          <p:cNvPr id="31" name="Text 20"/>
+          <p:cNvSpPr/>
+          <p:nvPr/>
+        </p:nvSpPr>
+        <p:spPr>
+          <a:xfrm>
+            <a:off x="6278880" y="2377440"/>
+            <a:ext cx="2369820" cy="350520"/>
+          </a:xfrm>
+          <a:prstGeom prst="rect">
+            <a:avLst/>
+          </a:prstGeom>
+          <a:noFill/>
+          <a:ln/>
+        </p:spPr>
+        <p:txBody>
+          <a:bodyPr wrap="square" lIns="0" tIns="0" rIns="0" bIns="0" rtlCol="0" anchor="ctr"/>
+          <a:lstStyle/>
+          <a:p>
+            <a:pPr algn="l" indent="0" marL="0">
+              <a:lnSpc>
+                <a:spcPts val="2760"/>
+              </a:lnSpc>
+              <a:buNone/>
+            </a:pPr>
+            <a:r>
+              <a:rPr lang="en-US" sz="2400" b="1" dirty="0">
+                <a:solidFill>
+                  <a:srgbClr val="FFFFFF"/>
+                </a:solidFill>
+                <a:latin typeface="Microsoft YaHei" pitchFamily="34" charset="0"/>
+                <a:ea typeface="Microsoft YaHei" pitchFamily="34" charset="-122"/>
+                <a:cs typeface="Microsoft YaHei" pitchFamily="34" charset="-120"/>
+              </a:rPr>
+              <a:t>2004年</a:t>
+            </a:r>
+            <a:endParaRPr lang="en-US" sz="2400" dirty="0"/>
+          </a:p>
+        </p:txBody>
+      </p:sp>
+      <p:pic>
+        <p:nvPicPr>
+          <p:cNvPr id="32" name="Image 8" descr="preencoded.png">    </p:cNvPr>
+          <p:cNvPicPr>
+            <a:picLocks noChangeAspect="1"/>
+          </p:cNvPicPr>
+          <p:nvPr/>
+        </p:nvPicPr>
+        <p:blipFill>
+          <a:blip r:embed="rId9"/>
+          <a:stretch>
+            <a:fillRect/>
+          </a:stretch>
+        </p:blipFill>
+        <p:spPr>
+          <a:xfrm>
+            <a:off x="6278880" y="2895600"/>
+            <a:ext cx="2369820" cy="1155978"/>
+          </a:xfrm>
+          <a:prstGeom prst="rect">
+            <a:avLst/>
+          </a:prstGeom>
+        </p:spPr>
+      </p:pic>
+      <p:sp>
+        <p:nvSpPr>
+          <p:cNvPr id="33" name="Text 21"/>
+          <p:cNvSpPr/>
+          <p:nvPr/>
+        </p:nvSpPr>
+        <p:spPr>
+          <a:xfrm>
+            <a:off x="6278880" y="4173498"/>
+            <a:ext cx="2369820" cy="1343382"/>
+          </a:xfrm>
+          <a:prstGeom prst="rect">
+            <a:avLst/>
+          </a:prstGeom>
+          <a:noFill/>
+          <a:ln/>
+        </p:spPr>
+        <p:txBody>
+          <a:bodyPr wrap="square" lIns="0" tIns="0" rIns="0" bIns="0" rtlCol="0" anchor="ctr"/>
+          <a:lstStyle/>
+          <a:p>
+            <a:pPr algn="just" indent="0" marL="0">
+              <a:lnSpc>
+                <a:spcPts val="2100"/>
+              </a:lnSpc>
+              <a:buNone/>
+            </a:pPr>
+            <a:r>
+              <a:rPr lang="en-US" sz="1400" dirty="0">
+                <a:solidFill>
+                  <a:srgbClr val="18383F"/>
+                </a:solidFill>
+                <a:latin typeface="Microsoft YaHei" pitchFamily="34" charset="0"/>
+                <a:ea typeface="Microsoft YaHei" pitchFamily="34" charset="-122"/>
+                <a:cs typeface="Microsoft YaHei" pitchFamily="34" charset="-120"/>
+              </a:rPr>
+              <a:t>经教育部批准，学校升格更名为丽水学院。在原有办学基础上拓展本科教育，逐步形成多学科协调发展的格局。</a:t>
+            </a:r>
+            <a:endParaRPr lang="en-US" sz="1400" dirty="0"/>
+          </a:p>
+        </p:txBody>
+      </p:sp>
+      <p:sp>
+        <p:nvSpPr>
+          <p:cNvPr id="34" name="Text 22"/>
+          <p:cNvSpPr/>
+          <p:nvPr/>
+        </p:nvSpPr>
+        <p:spPr>
+          <a:xfrm>
+            <a:off x="6309360" y="5823585"/>
+            <a:ext cx="1371600" cy="285750"/>
+          </a:xfrm>
+          <a:prstGeom prst="rect">
+            <a:avLst/>
+          </a:prstGeom>
+          <a:noFill/>
+          <a:ln/>
+        </p:spPr>
+        <p:txBody>
+          <a:bodyPr wrap="square" lIns="0" tIns="0" rIns="0" bIns="0" rtlCol="0" anchor="ctr"/>
+          <a:lstStyle/>
+          <a:p>
+            <a:pPr algn="l" indent="0" marL="0">
+              <a:lnSpc>
+                <a:spcPts val="2250"/>
+              </a:lnSpc>
+              <a:buNone/>
+            </a:pPr>
+            <a:r>
+              <a:rPr lang="en-US" sz="1800" b="1" dirty="0">
+                <a:solidFill>
+                  <a:srgbClr val="0F6674"/>
+                </a:solidFill>
+                <a:latin typeface="Microsoft YaHei" pitchFamily="34" charset="0"/>
+                <a:ea typeface="Microsoft YaHei" pitchFamily="34" charset="-122"/>
+                <a:cs typeface="Microsoft YaHei" pitchFamily="34" charset="-120"/>
+              </a:rPr>
+              <a:t>升本拓展格局</a:t>
+            </a:r>
+            <a:endParaRPr lang="en-US" sz="1800" dirty="0"/>
+          </a:p>
+        </p:txBody>
+      </p:sp>
+      <p:pic>
+        <p:nvPicPr>
+          <p:cNvPr id="35" name="Image 9" descr="preencoded.png">    </p:cNvPr>
+          <p:cNvPicPr>
+            <a:picLocks noChangeAspect="1"/>
+          </p:cNvPicPr>
+          <p:nvPr/>
+        </p:nvPicPr>
+        <p:blipFill>
+          <a:blip r:embed="rId10"/>
+          <a:stretch>
+            <a:fillRect/>
+          </a:stretch>
+        </p:blipFill>
+        <p:spPr>
+          <a:xfrm>
+            <a:off x="6141720" y="2331720"/>
+            <a:ext cx="30480" cy="3634740"/>
+          </a:xfrm>
+          <a:prstGeom prst="rect">
+            <a:avLst/>
+          </a:prstGeom>
+        </p:spPr>
+      </p:pic>
+      <p:pic>
+        <p:nvPicPr>
+          <p:cNvPr id="36" name="Image 10" descr="preencoded.png">    </p:cNvPr>
+          <p:cNvPicPr>
+            <a:picLocks noChangeAspect="1"/>
+          </p:cNvPicPr>
+          <p:nvPr/>
+        </p:nvPicPr>
+        <p:blipFill>
+          <a:blip r:embed="rId11"/>
+          <a:stretch>
+            <a:fillRect/>
+          </a:stretch>
+        </p:blipFill>
+        <p:spPr>
+          <a:xfrm>
+            <a:off x="6065520" y="5875020"/>
+            <a:ext cx="182880" cy="182880"/>
+          </a:xfrm>
+          <a:prstGeom prst="rect">
+            <a:avLst/>
+          </a:prstGeom>
+        </p:spPr>
+      </p:pic>
+      <p:sp>
+        <p:nvSpPr>
+          <p:cNvPr id="37" name="Shape 23"/>
+          <p:cNvSpPr/>
+          <p:nvPr/>
+        </p:nvSpPr>
+        <p:spPr>
+          <a:xfrm>
+            <a:off x="8892540" y="2331720"/>
+            <a:ext cx="2613660" cy="3276600"/>
+          </a:xfrm>
+          <a:prstGeom prst="rect">
+            <a:avLst/>
+          </a:prstGeom>
+          <a:solidFill>
+            <a:srgbClr val="EDF6F5"/>
+          </a:solidFill>
+          <a:ln w="12700">
+            <a:solidFill>
+              <a:srgbClr val="EDF6F5">
+                <a:alpha val="0"/>
+              </a:srgbClr>
+            </a:solidFill>
+            <a:prstDash val="solid"/>
+          </a:ln>
+        </p:spPr>
+      </p:sp>
+      <p:sp>
+        <p:nvSpPr>
+          <p:cNvPr id="38" name="Shape 24"/>
+          <p:cNvSpPr/>
+          <p:nvPr/>
+        </p:nvSpPr>
+        <p:spPr>
+          <a:xfrm>
+            <a:off x="8892540" y="2331720"/>
+            <a:ext cx="2613660" cy="441960"/>
+          </a:xfrm>
+          <a:prstGeom prst="rect">
+            <a:avLst/>
+          </a:prstGeom>
+          <a:solidFill>
+            <a:srgbClr val="0F6674"/>
+          </a:solidFill>
+          <a:ln w="12700">
+            <a:solidFill>
+              <a:srgbClr val="0F6674">
+                <a:alpha val="0"/>
+              </a:srgbClr>
+            </a:solidFill>
+            <a:prstDash val="solid"/>
+          </a:ln>
+        </p:spPr>
+      </p:sp>
+      <p:sp>
+        <p:nvSpPr>
+          <p:cNvPr id="39" name="Text 25"/>
+          <p:cNvSpPr/>
+          <p:nvPr/>
+        </p:nvSpPr>
+        <p:spPr>
+          <a:xfrm>
+            <a:off x="9014460" y="2377440"/>
+            <a:ext cx="2369820" cy="350520"/>
+          </a:xfrm>
+          <a:prstGeom prst="rect">
+            <a:avLst/>
+          </a:prstGeom>
+          <a:noFill/>
+          <a:ln/>
+        </p:spPr>
+        <p:txBody>
+          <a:bodyPr wrap="square" lIns="0" tIns="0" rIns="0" bIns="0" rtlCol="0" anchor="ctr"/>
+          <a:lstStyle/>
+          <a:p>
+            <a:pPr algn="l" indent="0" marL="0">
+              <a:lnSpc>
+                <a:spcPts val="2760"/>
+              </a:lnSpc>
+              <a:buNone/>
+            </a:pPr>
+            <a:r>
+              <a:rPr lang="en-US" sz="2400" b="1" dirty="0">
+                <a:solidFill>
+                  <a:srgbClr val="FFFFFF"/>
+                </a:solidFill>
+                <a:latin typeface="Microsoft YaHei" pitchFamily="34" charset="0"/>
+                <a:ea typeface="Microsoft YaHei" pitchFamily="34" charset="-122"/>
+                <a:cs typeface="Microsoft YaHei" pitchFamily="34" charset="-120"/>
+              </a:rPr>
+              <a:t>新时代</a:t>
+            </a:r>
+            <a:endParaRPr lang="en-US" sz="2400" dirty="0"/>
+          </a:p>
+        </p:txBody>
+      </p:sp>
+      <p:pic>
+        <p:nvPicPr>
+          <p:cNvPr id="40" name="Image 11" descr="preencoded.png">    </p:cNvPr>
+          <p:cNvPicPr>
+            <a:picLocks noChangeAspect="1"/>
+          </p:cNvPicPr>
+          <p:nvPr/>
+        </p:nvPicPr>
+        <p:blipFill>
+          <a:blip r:embed="rId12"/>
+          <a:stretch>
+            <a:fillRect/>
+          </a:stretch>
+        </p:blipFill>
+        <p:spPr>
+          <a:xfrm>
+            <a:off x="9014460" y="2895600"/>
+            <a:ext cx="2369820" cy="1155978"/>
+          </a:xfrm>
+          <a:prstGeom prst="rect">
+            <a:avLst/>
+          </a:prstGeom>
+        </p:spPr>
+      </p:pic>
+      <p:sp>
+        <p:nvSpPr>
+          <p:cNvPr id="41" name="Text 26"/>
+          <p:cNvSpPr/>
+          <p:nvPr/>
+        </p:nvSpPr>
+        <p:spPr>
+          <a:xfrm>
+            <a:off x="9014460" y="4173498"/>
+            <a:ext cx="2369820" cy="1343382"/>
+          </a:xfrm>
+          <a:prstGeom prst="rect">
+            <a:avLst/>
+          </a:prstGeom>
+          <a:noFill/>
+          <a:ln/>
+        </p:spPr>
+        <p:txBody>
+          <a:bodyPr wrap="square" lIns="0" tIns="0" rIns="0" bIns="0" rtlCol="0" anchor="ctr"/>
+          <a:lstStyle/>
+          <a:p>
+            <a:pPr algn="just" indent="0" marL="0">
+              <a:lnSpc>
+                <a:spcPts val="2100"/>
+              </a:lnSpc>
+              <a:buNone/>
+            </a:pPr>
+            <a:r>
+              <a:rPr lang="en-US" sz="1400" dirty="0">
+                <a:solidFill>
+                  <a:srgbClr val="18383F"/>
+                </a:solidFill>
+                <a:latin typeface="Microsoft YaHei" pitchFamily="34" charset="0"/>
+                <a:ea typeface="Microsoft YaHei" pitchFamily="34" charset="-122"/>
+                <a:cs typeface="Microsoft YaHei" pitchFamily="34" charset="-120"/>
+              </a:rPr>
               <a:t>坚持应用型办学方向，立足丽水、面向区域发展需要。围绕人才培养与科研服务，推进学科建设与产教协同发展。</a:t>
             </a:r>
             <a:endParaRPr lang="en-US" sz="1400" dirty="0"/>
@@ -46898,13 +47375,13 @@
       </p:sp>
       <p:sp>
         <p:nvSpPr>
-          <p:cNvPr id="21" name="Text 12"/>
-          <p:cNvSpPr/>
-          <p:nvPr/>
-        </p:nvSpPr>
-        <p:spPr>
-          <a:xfrm>
-            <a:off x="838200" y="5808345"/>
+          <p:cNvPr id="42" name="Text 27"/>
+          <p:cNvSpPr/>
+          <p:nvPr/>
+        </p:nvSpPr>
+        <p:spPr>
+          <a:xfrm>
+            <a:off x="9044940" y="5823585"/>
             <a:ext cx="1371600" cy="285750"/>
           </a:xfrm>
           <a:prstGeom prst="rect">
@@ -46926,28 +47403,76 @@
             <a:r>
               <a:rPr lang="en-US" sz="1800" b="1" dirty="0">
                 <a:solidFill>
-                  <a:srgbClr val="18383F"/>
-                </a:solidFill>
-                <a:latin typeface="Microsoft YaHei" pitchFamily="34" charset="0"/>
-                <a:ea typeface="Microsoft YaHei" pitchFamily="34" charset="-122"/>
-                <a:cs typeface="Microsoft YaHei" pitchFamily="34" charset="-120"/>
-              </a:rPr>
-              <a:t>师范薪火初传</a:t>
+                  <a:srgbClr val="0F6674"/>
+                </a:solidFill>
+                <a:latin typeface="Microsoft YaHei" pitchFamily="34" charset="0"/>
+                <a:ea typeface="Microsoft YaHei" pitchFamily="34" charset="-122"/>
+                <a:cs typeface="Microsoft YaHei" pitchFamily="34" charset="-120"/>
+              </a:rPr>
+              <a:t>服务地方发展</a:t>
             </a:r>
             <a:endParaRPr lang="en-US" sz="1800" dirty="0"/>
           </a:p>
         </p:txBody>
       </p:sp>
-      <p:sp>
-        <p:nvSpPr>
-          <p:cNvPr id="22" name="Text 13"/>
-          <p:cNvSpPr/>
-          <p:nvPr/>
-        </p:nvSpPr>
-        <p:spPr>
-          <a:xfrm>
-            <a:off x="3573780" y="5808345"/>
-            <a:ext cx="1371600" cy="285750"/>
+      <p:pic>
+        <p:nvPicPr>
+          <p:cNvPr id="43" name="Image 12" descr="preencoded.png">    </p:cNvPr>
+          <p:cNvPicPr>
+            <a:picLocks noChangeAspect="1"/>
+          </p:cNvPicPr>
+          <p:nvPr/>
+        </p:nvPicPr>
+        <p:blipFill>
+          <a:blip r:embed="rId13"/>
+          <a:stretch>
+            <a:fillRect/>
+          </a:stretch>
+        </p:blipFill>
+        <p:spPr>
+          <a:xfrm>
+            <a:off x="8877300" y="2331720"/>
+            <a:ext cx="30480" cy="3634740"/>
+          </a:xfrm>
+          <a:prstGeom prst="rect">
+            <a:avLst/>
+          </a:prstGeom>
+        </p:spPr>
+      </p:pic>
+      <p:pic>
+        <p:nvPicPr>
+          <p:cNvPr id="44" name="Image 13" descr="preencoded.png">    </p:cNvPr>
+          <p:cNvPicPr>
+            <a:picLocks noChangeAspect="1"/>
+          </p:cNvPicPr>
+          <p:nvPr/>
+        </p:nvPicPr>
+        <p:blipFill>
+          <a:blip r:embed="rId14"/>
+          <a:stretch>
+            <a:fillRect/>
+          </a:stretch>
+        </p:blipFill>
+        <p:spPr>
+          <a:xfrm>
+            <a:off x="8801100" y="5875020"/>
+            <a:ext cx="182880" cy="182880"/>
+          </a:xfrm>
+          <a:prstGeom prst="rect">
+            <a:avLst/>
+          </a:prstGeom>
+        </p:spPr>
+      </p:pic>
+      <p:sp>
+        <p:nvSpPr>
+          <p:cNvPr id="45" name="Text 28"/>
+          <p:cNvSpPr/>
+          <p:nvPr/>
+        </p:nvSpPr>
+        <p:spPr>
+          <a:xfrm>
+            <a:off x="441960" y="6485334"/>
+            <a:ext cx="2971800" cy="181332"/>
           </a:xfrm>
           <a:prstGeom prst="rect">
             <a:avLst/>
@@ -46961,132 +47486,6 @@
           <a:p>
             <a:pPr algn="l" indent="0" marL="0">
               <a:lnSpc>
-                <a:spcPts val="2250"/>
-              </a:lnSpc>
-              <a:buNone/>
-            </a:pPr>
-            <a:r>
-              <a:rPr lang="en-US" sz="1800" b="1" dirty="0">
-                <a:solidFill>
-                  <a:srgbClr val="18383F"/>
-                </a:solidFill>
-                <a:latin typeface="Microsoft YaHei" pitchFamily="34" charset="0"/>
-                <a:ea typeface="Microsoft YaHei" pitchFamily="34" charset="-122"/>
-                <a:cs typeface="Microsoft YaHei" pitchFamily="34" charset="-120"/>
-              </a:rPr>
-              <a:t>重建延续文脉</a:t>
-            </a:r>
-            <a:endParaRPr lang="en-US" sz="1800" dirty="0"/>
-          </a:p>
-        </p:txBody>
-      </p:sp>
-      <p:sp>
-        <p:nvSpPr>
-          <p:cNvPr id="23" name="Text 14"/>
-          <p:cNvSpPr/>
-          <p:nvPr/>
-        </p:nvSpPr>
-        <p:spPr>
-          <a:xfrm>
-            <a:off x="6309360" y="5808345"/>
-            <a:ext cx="1371600" cy="285750"/>
-          </a:xfrm>
-          <a:prstGeom prst="rect">
-            <a:avLst/>
-          </a:prstGeom>
-          <a:noFill/>
-          <a:ln/>
-        </p:spPr>
-        <p:txBody>
-          <a:bodyPr wrap="square" lIns="0" tIns="0" rIns="0" bIns="0" rtlCol="0" anchor="ctr"/>
-          <a:lstStyle/>
-          <a:p>
-            <a:pPr algn="l" indent="0" marL="0">
-              <a:lnSpc>
-                <a:spcPts val="2250"/>
-              </a:lnSpc>
-              <a:buNone/>
-            </a:pPr>
-            <a:r>
-              <a:rPr lang="en-US" sz="1800" b="1" dirty="0">
-                <a:solidFill>
-                  <a:srgbClr val="18383F"/>
-                </a:solidFill>
-                <a:latin typeface="Microsoft YaHei" pitchFamily="34" charset="0"/>
-                <a:ea typeface="Microsoft YaHei" pitchFamily="34" charset="-122"/>
-                <a:cs typeface="Microsoft YaHei" pitchFamily="34" charset="-120"/>
-              </a:rPr>
-              <a:t>升本拓展格局</a:t>
-            </a:r>
-            <a:endParaRPr lang="en-US" sz="1800" dirty="0"/>
-          </a:p>
-        </p:txBody>
-      </p:sp>
-      <p:sp>
-        <p:nvSpPr>
-          <p:cNvPr id="24" name="Text 15"/>
-          <p:cNvSpPr/>
-          <p:nvPr/>
-        </p:nvSpPr>
-        <p:spPr>
-          <a:xfrm>
-            <a:off x="9044940" y="5808345"/>
-            <a:ext cx="1371600" cy="285750"/>
-          </a:xfrm>
-          <a:prstGeom prst="rect">
-            <a:avLst/>
-          </a:prstGeom>
-          <a:noFill/>
-          <a:ln/>
-        </p:spPr>
-        <p:txBody>
-          <a:bodyPr wrap="square" lIns="0" tIns="0" rIns="0" bIns="0" rtlCol="0" anchor="ctr"/>
-          <a:lstStyle/>
-          <a:p>
-            <a:pPr algn="l" indent="0" marL="0">
-              <a:lnSpc>
-                <a:spcPts val="2250"/>
-              </a:lnSpc>
-              <a:buNone/>
-            </a:pPr>
-            <a:r>
-              <a:rPr lang="en-US" sz="1800" b="1" dirty="0">
-                <a:solidFill>
-                  <a:srgbClr val="18383F"/>
-                </a:solidFill>
-                <a:latin typeface="Microsoft YaHei" pitchFamily="34" charset="0"/>
-                <a:ea typeface="Microsoft YaHei" pitchFamily="34" charset="-122"/>
-                <a:cs typeface="Microsoft YaHei" pitchFamily="34" charset="-120"/>
-              </a:rPr>
-              <a:t>服务地方发展</a:t>
-            </a:r>
-            <a:endParaRPr lang="en-US" sz="1800" dirty="0"/>
-          </a:p>
-        </p:txBody>
-      </p:sp>
-      <p:sp>
-        <p:nvSpPr>
-          <p:cNvPr id="25" name="Text 16"/>
-          <p:cNvSpPr/>
-          <p:nvPr/>
-        </p:nvSpPr>
-        <p:spPr>
-          <a:xfrm>
-            <a:off x="441960" y="6489144"/>
-            <a:ext cx="2286000" cy="181332"/>
-          </a:xfrm>
-          <a:prstGeom prst="rect">
-            <a:avLst/>
-          </a:prstGeom>
-          <a:noFill/>
-          <a:ln/>
-        </p:spPr>
-        <p:txBody>
-          <a:bodyPr wrap="square" lIns="0" tIns="0" rIns="0" bIns="0" rtlCol="0" anchor="ctr"/>
-          <a:lstStyle/>
-          <a:p>
-            <a:pPr algn="l" indent="0" marL="0">
-              <a:lnSpc>
                 <a:spcPts val="1428"/>
               </a:lnSpc>
               <a:buNone/>
@@ -47108,16 +47507,16 @@
       </p:sp>
       <p:sp>
         <p:nvSpPr>
-          <p:cNvPr id="26" name="Text 17">
-            <a:hlinkClick r:id="rId7" tooltip=""/>
+          <p:cNvPr id="46" name="Text 29">
+            <a:hlinkClick r:id="rId15" tooltip=""/>
           </p:cNvPr>
           <p:cNvSpPr/>
           <p:nvPr/>
         </p:nvSpPr>
         <p:spPr>
           <a:xfrm>
-            <a:off x="2910840" y="6492478"/>
-            <a:ext cx="8212455" cy="174784"/>
+            <a:off x="3596640" y="6485334"/>
+            <a:ext cx="7534632" cy="181332"/>
           </a:xfrm>
           <a:prstGeom prst="rect">
             <a:avLst/>
@@ -47131,7 +47530,7 @@
           <a:p>
             <a:pPr algn="r" indent="0" marL="0">
               <a:lnSpc>
-                <a:spcPts val="1377"/>
+                <a:spcPts val="1428"/>
               </a:lnSpc>
               <a:buNone/>
             </a:pPr>
@@ -47143,7 +47542,7 @@
                 <a:latin typeface="Microsoft YaHei" pitchFamily="34" charset="0"/>
                 <a:ea typeface="Microsoft YaHei" pitchFamily="34" charset="-122"/>
                 <a:cs typeface="Microsoft YaHei" pitchFamily="34" charset="-120"/>
-                <a:hlinkClick r:id="rId7" invalidUrl="" action="" tgtFrame="" tooltip="" history="1" highlightClick="0" endSnd="0">
+                <a:hlinkClick r:id="rId15" invalidUrl="" action="" tgtFrame="" tooltip="" history="1" highlightClick="0" endSnd="0">
                   <a:extLst>
                     <a:ext uri="{A12FA001-AC4F-418D-AE19-62706E023703}">
                       <ahyp:hlinkClr xmlns:ahyp="http://schemas.microsoft.com/office/drawing/2018/hyperlinkcolor" val="tx"/>
@@ -47159,23 +47558,23 @@
       </p:sp>
       <p:sp>
         <p:nvSpPr>
-          <p:cNvPr id="27" name="Text 18"/>
-          <p:cNvSpPr/>
-          <p:nvPr/>
-        </p:nvSpPr>
-        <p:spPr>
-          <a:xfrm>
-            <a:off x="11306175" y="6489144"/>
-            <a:ext cx="443865" cy="181332"/>
-          </a:xfrm>
-          <a:prstGeom prst="rect">
-            <a:avLst/>
-          </a:prstGeom>
-          <a:noFill/>
-          <a:ln/>
-        </p:spPr>
-        <p:txBody>
-          <a:bodyPr wrap="none" lIns="0" tIns="0" rIns="0" bIns="0" rtlCol="0" anchor="ctr"/>
+          <p:cNvPr id="47" name="Text 30"/>
+          <p:cNvSpPr/>
+          <p:nvPr/>
+        </p:nvSpPr>
+        <p:spPr>
+          <a:xfrm>
+            <a:off x="11314152" y="6485334"/>
+            <a:ext cx="435888" cy="181332"/>
+          </a:xfrm>
+          <a:prstGeom prst="rect">
+            <a:avLst/>
+          </a:prstGeom>
+          <a:noFill/>
+          <a:ln/>
+        </p:spPr>
+        <p:txBody>
+          <a:bodyPr wrap="square" lIns="0" tIns="0" rIns="0" bIns="0" rtlCol="0" anchor="ctr"/>
           <a:lstStyle/>
           <a:p>
             <a:pPr algn="l" indent="0" marL="0">
@@ -47198,6 +47597,33 @@
             <a:endParaRPr lang="en-US" sz="1020" dirty="0"/>
           </a:p>
         </p:txBody>
+      </p:sp>
+      <p:sp>
+        <p:nvSpPr>
+          <p:cNvPr id="48" name="Shape 31"/>
+          <p:cNvSpPr/>
+          <p:nvPr/>
+        </p:nvSpPr>
+        <p:spPr>
+          <a:xfrm>
+            <a:off x="441960" y="6355080"/>
+            <a:ext cx="11308080" cy="7620"/>
+          </a:xfrm>
+          <a:prstGeom prst="rect">
+            <a:avLst/>
+          </a:prstGeom>
+          <a:solidFill>
+            <a:srgbClr val="D8E2E9"/>
+          </a:solidFill>
+          <a:ln w="12700">
+            <a:solidFill>
+              <a:srgbClr val="D8E2E9">
+                <a:alpha val="0"/>
+              </a:srgbClr>
+            </a:solidFill>
+            <a:prstDash val="solid"/>
+          </a:ln>
+        </p:spPr>
       </p:sp>
     </p:spTree>
   </p:cSld>

</xml_diff>